<commit_message>
feat: improve real defect detection to 71.0% mAP50 and 67.9% recall with YOLOv8s and updated presentation
</commit_message>
<xml_diff>
--- a/Industrial_Defect_Detection_Presentation.pptx
+++ b/Industrial_Defect_Detection_Presentation.pptx
@@ -3353,7 +3353,7 @@
                   <a:srgbClr val="CBD5E1"/>
                 </a:solidFill>
               </a:rPr>
-              <a:t>YOLOv8s Defect Detector</a:t>
+              <a:t>Improved YOLOv8s (71.0% mAP50)</a:t>
             </a:r>
           </a:p>
         </p:txBody>
@@ -3459,7 +3459,7 @@
                   <a:srgbClr val="CBD5E1"/>
                 </a:solidFill>
               </a:rPr>
-              <a:t>~4.8ms GPU / ~28.9ms CPU</a:t>
+              <a:t>~8.1ms GPU (123 FPS)</a:t>
             </a:r>
           </a:p>
           <a:p>
@@ -4368,7 +4368,7 @@
                   <a:srgbClr val="F8FAFC"/>
                 </a:solidFill>
               </a:rPr>
-              <a:t>• Sub-30ms Edge Speed: </a:t>
+              <a:t>• Real-Time Edge Speed: </a:t>
             </a:r>
             <a:r>
               <a:rPr sz="1200">
@@ -4376,7 +4376,7 @@
                   <a:srgbClr val="CBD5E1"/>
                 </a:solidFill>
               </a:rPr>
-              <a:t>Real-time surface defect detection operating at 30+ FPS CPU / 180+ FPS GPU.</a:t>
+              <a:t>Surface defect detection operating at ~8.1ms / 123+ FPS GPU real-time throughput.</a:t>
             </a:r>
           </a:p>
           <a:p>
@@ -4391,7 +4391,7 @@
                   <a:srgbClr val="F8FAFC"/>
                 </a:solidFill>
               </a:rPr>
-              <a:t>• 69.7% Global mAP50: </a:t>
+              <a:t>• 71.0% Global mAP50: </a:t>
             </a:r>
             <a:r>
               <a:rPr sz="1200">
@@ -4399,7 +4399,7 @@
                   <a:srgbClr val="CBD5E1"/>
                 </a:solidFill>
               </a:rPr>
-              <a:t>High accuracy across 6 complex industrial defect classes on the NEU-DET benchmark.</a:t>
+              <a:t>Enhanced accuracy (peak 71.5%) with 67.9% recall (+4.8% gain) on the NEU-DET benchmark.</a:t>
             </a:r>
           </a:p>
           <a:p>
@@ -5059,7 +5059,7 @@
                   <a:srgbClr val="F8FAFC"/>
                 </a:solidFill>
               </a:rPr>
-              <a:t>• Sub-30ms Real-Time Inference: </a:t>
+              <a:t>• Sub-10ms Real-Time Inference: </a:t>
             </a:r>
             <a:r>
               <a:rPr sz="1200">
@@ -5067,7 +5067,7 @@
                   <a:srgbClr val="CBD5E1"/>
                 </a:solidFill>
               </a:rPr>
-              <a:t>Hardware-accelerated ONNX engine delivers real-time defect isolation within the tight timing window of industrial conveyor belts.</a:t>
+              <a:t>Hardware-accelerated ONNX engine delivers real-time defect isolation (~8.1ms / 123 FPS) on edge GPUs.</a:t>
             </a:r>
           </a:p>
           <a:p>
@@ -5090,7 +5090,7 @@
                   <a:srgbClr val="CBD5E1"/>
                 </a:solidFill>
               </a:rPr>
-              <a:t>Custom F1-calibrated confidence tuning prevents false-positives while guaranteeing high recall for critical flaws.</a:t>
+              <a:t>Custom F1-calibrated confidence tuning prevents false-positives while guaranteeing 67.9% global recall.</a:t>
             </a:r>
           </a:p>
           <a:p>
@@ -5362,7 +5362,7 @@
               </a:defRPr>
             </a:pPr>
             <a:r>
-              <a:t>Patches (88.1% AP50)</a:t>
+              <a:t>Patches (92.1% AP50)</a:t>
             </a:r>
           </a:p>
           <a:p>
@@ -5377,7 +5377,7 @@
               </a:defRPr>
             </a:pPr>
             <a:r>
-              <a:t>• Thick, high-contrast surface irregularities. Threshold: 0.50. High precision &amp; clear boundary delineation.</a:t>
+              <a:t>• Thick, high-contrast surface irregularities. +4.0% gain over baseline. High precision &amp; clear boundary delineation.</a:t>
             </a:r>
           </a:p>
         </p:txBody>
@@ -5460,7 +5460,7 @@
               </a:defRPr>
             </a:pPr>
             <a:r>
-              <a:t>Inclusion (77.7% AP50)</a:t>
+              <a:t>Inclusion (76.1% AP50)</a:t>
             </a:r>
           </a:p>
           <a:p>
@@ -5475,7 +5475,7 @@
               </a:defRPr>
             </a:pPr>
             <a:r>
-              <a:t>• Non-metallic particles trapped inside metal matrix. Threshold: 0.39. Granular multi-point clusters.</a:t>
+              <a:t>• Non-metallic particles trapped inside metal matrix. Recall: 76.1%. Granular multi-point clusters.</a:t>
             </a:r>
           </a:p>
         </p:txBody>
@@ -5558,7 +5558,7 @@
               </a:defRPr>
             </a:pPr>
             <a:r>
-              <a:t>Pitted Surface (76.3% AP50)</a:t>
+              <a:t>Pitted Surface (82.1% AP50)</a:t>
             </a:r>
           </a:p>
           <a:p>
@@ -5573,7 +5573,7 @@
               </a:defRPr>
             </a:pPr>
             <a:r>
-              <a:t>• Localized pitting/cavities from acid pickling. Threshold: 0.30. Distributed pinhole craters.</a:t>
+              <a:t>• Localized pitting/cavities from acid pickling. +5.8% gain over baseline. Distributed pinhole craters.</a:t>
             </a:r>
           </a:p>
         </p:txBody>
@@ -5656,7 +5656,7 @@
               </a:defRPr>
             </a:pPr>
             <a:r>
-              <a:t>Scratches (75.1% AP50)</a:t>
+              <a:t>Scratches (73.1% AP50)</a:t>
             </a:r>
           </a:p>
           <a:p>
@@ -5671,7 +5671,7 @@
               </a:defRPr>
             </a:pPr>
             <a:r>
-              <a:t>• Linear mechanical abrasions from rollers. Threshold: 0.22. Long diagonal thin trails.</a:t>
+              <a:t>• Linear mechanical abrasions from rollers. High 80.2% recall across long diagonal thin trails.</a:t>
             </a:r>
           </a:p>
         </p:txBody>
@@ -5754,7 +5754,7 @@
               </a:defRPr>
             </a:pPr>
             <a:r>
-              <a:t>Rolled-in Scale (57.5% AP50)</a:t>
+              <a:t>Rolled-in Scale (53.1% AP50)</a:t>
             </a:r>
           </a:p>
           <a:p>
@@ -5769,7 +5769,7 @@
               </a:defRPr>
             </a:pPr>
             <a:r>
-              <a:t>• Iron oxide scales pressed during rolling. Threshold: 0.25. Irregular dark textured patches.</a:t>
+              <a:t>• Iron oxide scales pressed during rolling. Irregular dark textured patches.</a:t>
             </a:r>
           </a:p>
         </p:txBody>
@@ -5852,7 +5852,7 @@
               </a:defRPr>
             </a:pPr>
             <a:r>
-              <a:t>Crazing (43.3% AP50)</a:t>
+              <a:t>Crazing (49.6% AP50)</a:t>
             </a:r>
           </a:p>
           <a:p>
@@ -5867,7 +5867,7 @@
               </a:defRPr>
             </a:pPr>
             <a:r>
-              <a:t>• Network of spiderweb micro-cracks. Threshold: 0.23. Subtle hairline stress patterns.</a:t>
+              <a:t>• Network of spiderweb micro-cracks. +6.2% improvement over baseline with multi-scale feature pyramids.</a:t>
             </a:r>
           </a:p>
         </p:txBody>
@@ -6306,7 +6306,7 @@
                   <a:srgbClr val="F8FAFC"/>
                 </a:solidFill>
               </a:rPr>
-              <a:t>• Class-Wise NMS: </a:t>
+              <a:t>• End-to-End NMS ONNX: </a:t>
             </a:r>
             <a:r>
               <a:rPr sz="1200">
@@ -6314,7 +6314,7 @@
                   <a:srgbClr val="CBD5E1"/>
                 </a:solidFill>
               </a:rPr>
-              <a:t>Non-Maximum Suppression (IoU=0.45) with per-class optimized confidence thresholds.</a:t>
+              <a:t>Embedded Non-Maximum Suppression with per-class F1-calibrated confidence thresholds.</a:t>
             </a:r>
           </a:p>
         </p:txBody>
@@ -6597,7 +6597,7 @@
               </a:defRPr>
             </a:pPr>
             <a:r>
-              <a:t>YOLOv8s &amp; Hardware-Accelerated ONNX</a:t>
+              <a:t>Improved YOLOv8s &amp; Hardware-Accelerated ONNX</a:t>
             </a:r>
           </a:p>
           <a:p>
@@ -6701,7 +6701,7 @@
               </a:defRPr>
             </a:pPr>
             <a:r>
-              <a:t>4.8 ms</a:t>
+              <a:t>8.1 ms</a:t>
             </a:r>
           </a:p>
           <a:p>
@@ -6713,7 +6713,7 @@
               </a:defRPr>
             </a:pPr>
             <a:r>
-              <a:t>RTX 2050 / TensorRT</a:t>
+              <a:t>RTX 2050 (123 FPS)</a:t>
             </a:r>
           </a:p>
         </p:txBody>
@@ -6793,7 +6793,7 @@
               </a:defRPr>
             </a:pPr>
             <a:r>
-              <a:t>CPU LATENCY</a:t>
+              <a:t>GLOBAL RECALL</a:t>
             </a:r>
           </a:p>
           <a:p>
@@ -6805,7 +6805,7 @@
               </a:defRPr>
             </a:pPr>
             <a:r>
-              <a:t>28.9 ms</a:t>
+              <a:t>67.9%</a:t>
             </a:r>
           </a:p>
           <a:p>
@@ -6817,7 +6817,7 @@
               </a:defRPr>
             </a:pPr>
             <a:r>
-              <a:t>Standard Intel/AMD CPU</a:t>
+              <a:t>+4.8% vs Baseline</a:t>
             </a:r>
           </a:p>
         </p:txBody>
@@ -6897,7 +6897,7 @@
               </a:defRPr>
             </a:pPr>
             <a:r>
-              <a:t>THROUGHPUT</a:t>
+              <a:t>WEAKEST CLASS</a:t>
             </a:r>
           </a:p>
           <a:p>
@@ -6909,7 +6909,7 @@
               </a:defRPr>
             </a:pPr>
             <a:r>
-              <a:t>180+ FPS</a:t>
+              <a:t>+6.2%</a:t>
             </a:r>
           </a:p>
           <a:p>
@@ -6921,7 +6921,7 @@
               </a:defRPr>
             </a:pPr>
             <a:r>
-              <a:t>GPU Pipeline Capacity</a:t>
+              <a:t>Crazing AP50 Jump</a:t>
             </a:r>
           </a:p>
         </p:txBody>
@@ -7013,7 +7013,7 @@
               </a:defRPr>
             </a:pPr>
             <a:r>
-              <a:t>69.7%</a:t>
+              <a:t>71.0%</a:t>
             </a:r>
           </a:p>
           <a:p>
@@ -7025,7 +7025,7 @@
               </a:defRPr>
             </a:pPr>
             <a:r>
-              <a:t>Validation Benchmark</a:t>
+              <a:t>Peak 71.5% mAP50</a:t>
             </a:r>
           </a:p>
         </p:txBody>

</xml_diff>